<commit_message>
Product- Some modification on form and db columns
</commit_message>
<xml_diff>
--- a/.lessons/58 Backend Product And Related Features/11 Product- Handling create product form/1.pptx
+++ b/.lessons/58 Backend Product And Related Features/11 Product- Handling create product form/1.pptx
@@ -6,8 +6,20 @@
   </p:sldMasterIdLst>
   <p:sldIdLst>
     <p:sldId id="413" r:id="rId2"/>
-    <p:sldId id="414" r:id="rId3"/>
-    <p:sldId id="400" r:id="rId4"/>
+    <p:sldId id="415" r:id="rId3"/>
+    <p:sldId id="416" r:id="rId4"/>
+    <p:sldId id="417" r:id="rId5"/>
+    <p:sldId id="418" r:id="rId6"/>
+    <p:sldId id="419" r:id="rId7"/>
+    <p:sldId id="414" r:id="rId8"/>
+    <p:sldId id="420" r:id="rId9"/>
+    <p:sldId id="425" r:id="rId10"/>
+    <p:sldId id="426" r:id="rId11"/>
+    <p:sldId id="427" r:id="rId12"/>
+    <p:sldId id="428" r:id="rId13"/>
+    <p:sldId id="429" r:id="rId14"/>
+    <p:sldId id="430" r:id="rId15"/>
+    <p:sldId id="400" r:id="rId16"/>
   </p:sldIdLst>
   <p:sldSz cx="12192000" cy="6858000"/>
   <p:notesSz cx="6858000" cy="9144000"/>
@@ -261,7 +273,7 @@
           <a:p>
             <a:fld id="{3E102D2E-813C-461C-9963-687A650C48C0}" type="datetimeFigureOut">
               <a:rPr lang="en-US" smtClean="0"/>
-              <a:t>6/26/2025</a:t>
+              <a:t>10/7/2025</a:t>
             </a:fld>
             <a:endParaRPr lang="en-US"/>
           </a:p>
@@ -459,7 +471,7 @@
           <a:p>
             <a:fld id="{3E102D2E-813C-461C-9963-687A650C48C0}" type="datetimeFigureOut">
               <a:rPr lang="en-US" smtClean="0"/>
-              <a:t>6/26/2025</a:t>
+              <a:t>10/7/2025</a:t>
             </a:fld>
             <a:endParaRPr lang="en-US"/>
           </a:p>
@@ -667,7 +679,7 @@
           <a:p>
             <a:fld id="{3E102D2E-813C-461C-9963-687A650C48C0}" type="datetimeFigureOut">
               <a:rPr lang="en-US" smtClean="0"/>
-              <a:t>6/26/2025</a:t>
+              <a:t>10/7/2025</a:t>
             </a:fld>
             <a:endParaRPr lang="en-US"/>
           </a:p>
@@ -865,7 +877,7 @@
           <a:p>
             <a:fld id="{3E102D2E-813C-461C-9963-687A650C48C0}" type="datetimeFigureOut">
               <a:rPr lang="en-US" smtClean="0"/>
-              <a:t>6/26/2025</a:t>
+              <a:t>10/7/2025</a:t>
             </a:fld>
             <a:endParaRPr lang="en-US"/>
           </a:p>
@@ -1140,7 +1152,7 @@
           <a:p>
             <a:fld id="{3E102D2E-813C-461C-9963-687A650C48C0}" type="datetimeFigureOut">
               <a:rPr lang="en-US" smtClean="0"/>
-              <a:t>6/26/2025</a:t>
+              <a:t>10/7/2025</a:t>
             </a:fld>
             <a:endParaRPr lang="en-US"/>
           </a:p>
@@ -1405,7 +1417,7 @@
           <a:p>
             <a:fld id="{3E102D2E-813C-461C-9963-687A650C48C0}" type="datetimeFigureOut">
               <a:rPr lang="en-US" smtClean="0"/>
-              <a:t>6/26/2025</a:t>
+              <a:t>10/7/2025</a:t>
             </a:fld>
             <a:endParaRPr lang="en-US"/>
           </a:p>
@@ -1817,7 +1829,7 @@
           <a:p>
             <a:fld id="{3E102D2E-813C-461C-9963-687A650C48C0}" type="datetimeFigureOut">
               <a:rPr lang="en-US" smtClean="0"/>
-              <a:t>6/26/2025</a:t>
+              <a:t>10/7/2025</a:t>
             </a:fld>
             <a:endParaRPr lang="en-US"/>
           </a:p>
@@ -1958,7 +1970,7 @@
           <a:p>
             <a:fld id="{3E102D2E-813C-461C-9963-687A650C48C0}" type="datetimeFigureOut">
               <a:rPr lang="en-US" smtClean="0"/>
-              <a:t>6/26/2025</a:t>
+              <a:t>10/7/2025</a:t>
             </a:fld>
             <a:endParaRPr lang="en-US"/>
           </a:p>
@@ -2071,7 +2083,7 @@
           <a:p>
             <a:fld id="{3E102D2E-813C-461C-9963-687A650C48C0}" type="datetimeFigureOut">
               <a:rPr lang="en-US" smtClean="0"/>
-              <a:t>6/26/2025</a:t>
+              <a:t>10/7/2025</a:t>
             </a:fld>
             <a:endParaRPr lang="en-US"/>
           </a:p>
@@ -2382,7 +2394,7 @@
           <a:p>
             <a:fld id="{3E102D2E-813C-461C-9963-687A650C48C0}" type="datetimeFigureOut">
               <a:rPr lang="en-US" smtClean="0"/>
-              <a:t>6/26/2025</a:t>
+              <a:t>10/7/2025</a:t>
             </a:fld>
             <a:endParaRPr lang="en-US"/>
           </a:p>
@@ -2670,7 +2682,7 @@
           <a:p>
             <a:fld id="{3E102D2E-813C-461C-9963-687A650C48C0}" type="datetimeFigureOut">
               <a:rPr lang="en-US" smtClean="0"/>
-              <a:t>6/26/2025</a:t>
+              <a:t>10/7/2025</a:t>
             </a:fld>
             <a:endParaRPr lang="en-US"/>
           </a:p>
@@ -2911,7 +2923,7 @@
           <a:p>
             <a:fld id="{3E102D2E-813C-461C-9963-687A650C48C0}" type="datetimeFigureOut">
               <a:rPr lang="en-US" smtClean="0"/>
-              <a:t>6/26/2025</a:t>
+              <a:t>10/7/2025</a:t>
             </a:fld>
             <a:endParaRPr lang="en-US"/>
           </a:p>
@@ -3369,21 +3381,78 @@
               <a:buNone/>
             </a:pPr>
             <a:r>
-              <a:rPr kumimoji="0" lang="en-US" altLang="en-US" sz="1300" b="0" i="0" u="none" strike="noStrike" cap="none" normalizeH="0" baseline="0">
-                <a:ln>
-                  <a:noFill/>
-                </a:ln>
-                <a:solidFill>
-                  <a:schemeClr val="tx1"/>
-                </a:solidFill>
-                <a:effectLst/>
+              <a:rPr lang="en-US" altLang="en-US" sz="1300" b="1">
                 <a:latin typeface="Arial" panose="020B0604020202020204" pitchFamily="34" charset="0"/>
               </a:rPr>
-              <a:t>.</a:t>
-            </a:r>
-          </a:p>
-        </p:txBody>
-      </p:sp>
+              <a:t>app\Models\User.php</a:t>
+            </a:r>
+            <a:r>
+              <a:rPr lang="az-Latn-AZ" altLang="en-US" sz="1300" b="1">
+                <a:latin typeface="Arial" panose="020B0604020202020204" pitchFamily="34" charset="0"/>
+              </a:rPr>
+              <a:t> </a:t>
+            </a:r>
+            <a:r>
+              <a:rPr lang="az-Latn-AZ" altLang="en-US" sz="1300">
+                <a:latin typeface="Arial" panose="020B0604020202020204" pitchFamily="34" charset="0"/>
+              </a:rPr>
+              <a:t>faylına </a:t>
+            </a:r>
+            <a:r>
+              <a:rPr lang="az-Latn-AZ" altLang="en-US" sz="1300" b="1">
+                <a:latin typeface="Arial" panose="020B0604020202020204" pitchFamily="34" charset="0"/>
+              </a:rPr>
+              <a:t>vendor() </a:t>
+            </a:r>
+            <a:r>
+              <a:rPr lang="az-Latn-AZ" altLang="en-US" sz="1300">
+                <a:latin typeface="Arial" panose="020B0604020202020204" pitchFamily="34" charset="0"/>
+              </a:rPr>
+              <a:t>metodunu əlavə edirik.</a:t>
+            </a:r>
+            <a:endParaRPr kumimoji="0" lang="en-US" altLang="en-US" sz="1300" b="0" i="0" u="none" strike="noStrike" cap="none" normalizeH="0" baseline="0">
+              <a:ln>
+                <a:noFill/>
+              </a:ln>
+              <a:solidFill>
+                <a:schemeClr val="tx1"/>
+              </a:solidFill>
+              <a:effectLst/>
+              <a:latin typeface="Arial" panose="020B0604020202020204" pitchFamily="34" charset="0"/>
+            </a:endParaRPr>
+          </a:p>
+        </p:txBody>
+      </p:sp>
+      <p:pic>
+        <p:nvPicPr>
+          <p:cNvPr id="4" name="Picture 3">
+            <a:extLst>
+              <a:ext uri="{FF2B5EF4-FFF2-40B4-BE49-F238E27FC236}">
+                <a16:creationId xmlns:a16="http://schemas.microsoft.com/office/drawing/2014/main" id="{8F9865E7-30AD-7EA4-4F50-3EC17C6FFCB5}"/>
+              </a:ext>
+            </a:extLst>
+          </p:cNvPr>
+          <p:cNvPicPr>
+            <a:picLocks noChangeAspect="1"/>
+          </p:cNvPicPr>
+          <p:nvPr/>
+        </p:nvPicPr>
+        <p:blipFill>
+          <a:blip r:embed="rId2"/>
+          <a:stretch>
+            <a:fillRect/>
+          </a:stretch>
+        </p:blipFill>
+        <p:spPr>
+          <a:xfrm>
+            <a:off x="7412459" y="0"/>
+            <a:ext cx="4779541" cy="6858000"/>
+          </a:xfrm>
+          <a:prstGeom prst="rect">
+            <a:avLst/>
+          </a:prstGeom>
+        </p:spPr>
+      </p:pic>
     </p:spTree>
     <p:extLst>
       <p:ext uri="{BB962C8B-B14F-4D97-AF65-F5344CB8AC3E}">
@@ -3397,7 +3466,1185 @@
 </p:sld>
 </file>
 
+<file path=ppt/slides/slide10.xml><?xml version="1.0" encoding="utf-8"?>
+<p:sld xmlns:a="http://schemas.openxmlformats.org/drawingml/2006/main" xmlns:r="http://schemas.openxmlformats.org/officeDocument/2006/relationships" xmlns:p="http://schemas.openxmlformats.org/presentationml/2006/main">
+  <p:cSld>
+    <p:spTree>
+      <p:nvGrpSpPr>
+        <p:cNvPr id="1" name="">
+          <a:extLst>
+            <a:ext uri="{FF2B5EF4-FFF2-40B4-BE49-F238E27FC236}">
+              <a16:creationId xmlns:a16="http://schemas.microsoft.com/office/drawing/2014/main" id="{A07CF23F-B2A3-5B37-7E21-24A5CE009541}"/>
+            </a:ext>
+          </a:extLst>
+        </p:cNvPr>
+        <p:cNvGrpSpPr/>
+        <p:nvPr/>
+      </p:nvGrpSpPr>
+      <p:grpSpPr>
+        <a:xfrm>
+          <a:off x="0" y="0"/>
+          <a:ext cx="0" cy="0"/>
+          <a:chOff x="0" y="0"/>
+          <a:chExt cx="0" cy="0"/>
+        </a:xfrm>
+      </p:grpSpPr>
+      <p:sp>
+        <p:nvSpPr>
+          <p:cNvPr id="3" name="TextBox 2">
+            <a:extLst>
+              <a:ext uri="{FF2B5EF4-FFF2-40B4-BE49-F238E27FC236}">
+                <a16:creationId xmlns:a16="http://schemas.microsoft.com/office/drawing/2014/main" id="{F5086FFC-CA14-C394-ED9E-5215A9644346}"/>
+              </a:ext>
+            </a:extLst>
+          </p:cNvPr>
+          <p:cNvSpPr txBox="1"/>
+          <p:nvPr/>
+        </p:nvSpPr>
+        <p:spPr>
+          <a:xfrm>
+            <a:off x="217714" y="255046"/>
+            <a:ext cx="11756571" cy="355354"/>
+          </a:xfrm>
+          <a:prstGeom prst="rect">
+            <a:avLst/>
+          </a:prstGeom>
+          <a:noFill/>
+        </p:spPr>
+        <p:txBody>
+          <a:bodyPr wrap="square">
+            <a:spAutoFit/>
+          </a:bodyPr>
+          <a:lstStyle/>
+          <a:p>
+            <a:pPr>
+              <a:lnSpc>
+                <a:spcPct val="150000"/>
+              </a:lnSpc>
+              <a:buNone/>
+            </a:pPr>
+            <a:r>
+              <a:rPr kumimoji="0" lang="en-US" altLang="en-US" sz="1300" b="0" i="0" u="none" strike="noStrike" cap="none" normalizeH="0" baseline="0">
+                <a:ln>
+                  <a:noFill/>
+                </a:ln>
+                <a:solidFill>
+                  <a:schemeClr val="tx1"/>
+                </a:solidFill>
+                <a:effectLst/>
+                <a:latin typeface="Arial" panose="020B0604020202020204" pitchFamily="34" charset="0"/>
+              </a:rPr>
+              <a:t>.</a:t>
+            </a:r>
+          </a:p>
+        </p:txBody>
+      </p:sp>
+    </p:spTree>
+    <p:extLst>
+      <p:ext uri="{BB962C8B-B14F-4D97-AF65-F5344CB8AC3E}">
+        <p14:creationId xmlns:p14="http://schemas.microsoft.com/office/powerpoint/2010/main" val="3453344562"/>
+      </p:ext>
+    </p:extLst>
+  </p:cSld>
+  <p:clrMapOvr>
+    <a:masterClrMapping/>
+  </p:clrMapOvr>
+</p:sld>
+</file>
+
+<file path=ppt/slides/slide11.xml><?xml version="1.0" encoding="utf-8"?>
+<p:sld xmlns:a="http://schemas.openxmlformats.org/drawingml/2006/main" xmlns:r="http://schemas.openxmlformats.org/officeDocument/2006/relationships" xmlns:p="http://schemas.openxmlformats.org/presentationml/2006/main">
+  <p:cSld>
+    <p:spTree>
+      <p:nvGrpSpPr>
+        <p:cNvPr id="1" name="">
+          <a:extLst>
+            <a:ext uri="{FF2B5EF4-FFF2-40B4-BE49-F238E27FC236}">
+              <a16:creationId xmlns:a16="http://schemas.microsoft.com/office/drawing/2014/main" id="{2CCC57A5-6B25-F0D1-C4C4-E1B0E78AD5D1}"/>
+            </a:ext>
+          </a:extLst>
+        </p:cNvPr>
+        <p:cNvGrpSpPr/>
+        <p:nvPr/>
+      </p:nvGrpSpPr>
+      <p:grpSpPr>
+        <a:xfrm>
+          <a:off x="0" y="0"/>
+          <a:ext cx="0" cy="0"/>
+          <a:chOff x="0" y="0"/>
+          <a:chExt cx="0" cy="0"/>
+        </a:xfrm>
+      </p:grpSpPr>
+      <p:sp>
+        <p:nvSpPr>
+          <p:cNvPr id="3" name="TextBox 2">
+            <a:extLst>
+              <a:ext uri="{FF2B5EF4-FFF2-40B4-BE49-F238E27FC236}">
+                <a16:creationId xmlns:a16="http://schemas.microsoft.com/office/drawing/2014/main" id="{60173097-E0D4-4787-9123-150E8DF584CA}"/>
+              </a:ext>
+            </a:extLst>
+          </p:cNvPr>
+          <p:cNvSpPr txBox="1"/>
+          <p:nvPr/>
+        </p:nvSpPr>
+        <p:spPr>
+          <a:xfrm>
+            <a:off x="217714" y="255046"/>
+            <a:ext cx="11756571" cy="355354"/>
+          </a:xfrm>
+          <a:prstGeom prst="rect">
+            <a:avLst/>
+          </a:prstGeom>
+          <a:noFill/>
+        </p:spPr>
+        <p:txBody>
+          <a:bodyPr wrap="square">
+            <a:spAutoFit/>
+          </a:bodyPr>
+          <a:lstStyle/>
+          <a:p>
+            <a:pPr>
+              <a:lnSpc>
+                <a:spcPct val="150000"/>
+              </a:lnSpc>
+              <a:buNone/>
+            </a:pPr>
+            <a:r>
+              <a:rPr kumimoji="0" lang="en-US" altLang="en-US" sz="1300" b="0" i="0" u="none" strike="noStrike" cap="none" normalizeH="0" baseline="0">
+                <a:ln>
+                  <a:noFill/>
+                </a:ln>
+                <a:solidFill>
+                  <a:schemeClr val="tx1"/>
+                </a:solidFill>
+                <a:effectLst/>
+                <a:latin typeface="Arial" panose="020B0604020202020204" pitchFamily="34" charset="0"/>
+              </a:rPr>
+              <a:t>.</a:t>
+            </a:r>
+          </a:p>
+        </p:txBody>
+      </p:sp>
+    </p:spTree>
+    <p:extLst>
+      <p:ext uri="{BB962C8B-B14F-4D97-AF65-F5344CB8AC3E}">
+        <p14:creationId xmlns:p14="http://schemas.microsoft.com/office/powerpoint/2010/main" val="1699559272"/>
+      </p:ext>
+    </p:extLst>
+  </p:cSld>
+  <p:clrMapOvr>
+    <a:masterClrMapping/>
+  </p:clrMapOvr>
+</p:sld>
+</file>
+
+<file path=ppt/slides/slide12.xml><?xml version="1.0" encoding="utf-8"?>
+<p:sld xmlns:a="http://schemas.openxmlformats.org/drawingml/2006/main" xmlns:r="http://schemas.openxmlformats.org/officeDocument/2006/relationships" xmlns:p="http://schemas.openxmlformats.org/presentationml/2006/main">
+  <p:cSld>
+    <p:spTree>
+      <p:nvGrpSpPr>
+        <p:cNvPr id="1" name="">
+          <a:extLst>
+            <a:ext uri="{FF2B5EF4-FFF2-40B4-BE49-F238E27FC236}">
+              <a16:creationId xmlns:a16="http://schemas.microsoft.com/office/drawing/2014/main" id="{5E71D959-AEBE-48B7-9357-336956999FC5}"/>
+            </a:ext>
+          </a:extLst>
+        </p:cNvPr>
+        <p:cNvGrpSpPr/>
+        <p:nvPr/>
+      </p:nvGrpSpPr>
+      <p:grpSpPr>
+        <a:xfrm>
+          <a:off x="0" y="0"/>
+          <a:ext cx="0" cy="0"/>
+          <a:chOff x="0" y="0"/>
+          <a:chExt cx="0" cy="0"/>
+        </a:xfrm>
+      </p:grpSpPr>
+      <p:sp>
+        <p:nvSpPr>
+          <p:cNvPr id="3" name="TextBox 2">
+            <a:extLst>
+              <a:ext uri="{FF2B5EF4-FFF2-40B4-BE49-F238E27FC236}">
+                <a16:creationId xmlns:a16="http://schemas.microsoft.com/office/drawing/2014/main" id="{74D10F23-063A-4CD5-0E83-F630440A1A2B}"/>
+              </a:ext>
+            </a:extLst>
+          </p:cNvPr>
+          <p:cNvSpPr txBox="1"/>
+          <p:nvPr/>
+        </p:nvSpPr>
+        <p:spPr>
+          <a:xfrm>
+            <a:off x="217714" y="255046"/>
+            <a:ext cx="11756571" cy="355354"/>
+          </a:xfrm>
+          <a:prstGeom prst="rect">
+            <a:avLst/>
+          </a:prstGeom>
+          <a:noFill/>
+        </p:spPr>
+        <p:txBody>
+          <a:bodyPr wrap="square">
+            <a:spAutoFit/>
+          </a:bodyPr>
+          <a:lstStyle/>
+          <a:p>
+            <a:pPr>
+              <a:lnSpc>
+                <a:spcPct val="150000"/>
+              </a:lnSpc>
+              <a:buNone/>
+            </a:pPr>
+            <a:r>
+              <a:rPr kumimoji="0" lang="en-US" altLang="en-US" sz="1300" b="0" i="0" u="none" strike="noStrike" cap="none" normalizeH="0" baseline="0">
+                <a:ln>
+                  <a:noFill/>
+                </a:ln>
+                <a:solidFill>
+                  <a:schemeClr val="tx1"/>
+                </a:solidFill>
+                <a:effectLst/>
+                <a:latin typeface="Arial" panose="020B0604020202020204" pitchFamily="34" charset="0"/>
+              </a:rPr>
+              <a:t>.</a:t>
+            </a:r>
+          </a:p>
+        </p:txBody>
+      </p:sp>
+    </p:spTree>
+    <p:extLst>
+      <p:ext uri="{BB962C8B-B14F-4D97-AF65-F5344CB8AC3E}">
+        <p14:creationId xmlns:p14="http://schemas.microsoft.com/office/powerpoint/2010/main" val="3965731254"/>
+      </p:ext>
+    </p:extLst>
+  </p:cSld>
+  <p:clrMapOvr>
+    <a:masterClrMapping/>
+  </p:clrMapOvr>
+</p:sld>
+</file>
+
+<file path=ppt/slides/slide13.xml><?xml version="1.0" encoding="utf-8"?>
+<p:sld xmlns:a="http://schemas.openxmlformats.org/drawingml/2006/main" xmlns:r="http://schemas.openxmlformats.org/officeDocument/2006/relationships" xmlns:p="http://schemas.openxmlformats.org/presentationml/2006/main">
+  <p:cSld>
+    <p:spTree>
+      <p:nvGrpSpPr>
+        <p:cNvPr id="1" name="">
+          <a:extLst>
+            <a:ext uri="{FF2B5EF4-FFF2-40B4-BE49-F238E27FC236}">
+              <a16:creationId xmlns:a16="http://schemas.microsoft.com/office/drawing/2014/main" id="{0BAA4A92-31DF-0FF2-7A45-4CA6083604DF}"/>
+            </a:ext>
+          </a:extLst>
+        </p:cNvPr>
+        <p:cNvGrpSpPr/>
+        <p:nvPr/>
+      </p:nvGrpSpPr>
+      <p:grpSpPr>
+        <a:xfrm>
+          <a:off x="0" y="0"/>
+          <a:ext cx="0" cy="0"/>
+          <a:chOff x="0" y="0"/>
+          <a:chExt cx="0" cy="0"/>
+        </a:xfrm>
+      </p:grpSpPr>
+      <p:sp>
+        <p:nvSpPr>
+          <p:cNvPr id="3" name="TextBox 2">
+            <a:extLst>
+              <a:ext uri="{FF2B5EF4-FFF2-40B4-BE49-F238E27FC236}">
+                <a16:creationId xmlns:a16="http://schemas.microsoft.com/office/drawing/2014/main" id="{3896C4DF-B248-9297-74A7-2792BF2EB3FB}"/>
+              </a:ext>
+            </a:extLst>
+          </p:cNvPr>
+          <p:cNvSpPr txBox="1"/>
+          <p:nvPr/>
+        </p:nvSpPr>
+        <p:spPr>
+          <a:xfrm>
+            <a:off x="217714" y="255046"/>
+            <a:ext cx="11756571" cy="355354"/>
+          </a:xfrm>
+          <a:prstGeom prst="rect">
+            <a:avLst/>
+          </a:prstGeom>
+          <a:noFill/>
+        </p:spPr>
+        <p:txBody>
+          <a:bodyPr wrap="square">
+            <a:spAutoFit/>
+          </a:bodyPr>
+          <a:lstStyle/>
+          <a:p>
+            <a:pPr>
+              <a:lnSpc>
+                <a:spcPct val="150000"/>
+              </a:lnSpc>
+              <a:buNone/>
+            </a:pPr>
+            <a:r>
+              <a:rPr kumimoji="0" lang="en-US" altLang="en-US" sz="1300" b="0" i="0" u="none" strike="noStrike" cap="none" normalizeH="0" baseline="0">
+                <a:ln>
+                  <a:noFill/>
+                </a:ln>
+                <a:solidFill>
+                  <a:schemeClr val="tx1"/>
+                </a:solidFill>
+                <a:effectLst/>
+                <a:latin typeface="Arial" panose="020B0604020202020204" pitchFamily="34" charset="0"/>
+              </a:rPr>
+              <a:t>.</a:t>
+            </a:r>
+          </a:p>
+        </p:txBody>
+      </p:sp>
+    </p:spTree>
+    <p:extLst>
+      <p:ext uri="{BB962C8B-B14F-4D97-AF65-F5344CB8AC3E}">
+        <p14:creationId xmlns:p14="http://schemas.microsoft.com/office/powerpoint/2010/main" val="34309233"/>
+      </p:ext>
+    </p:extLst>
+  </p:cSld>
+  <p:clrMapOvr>
+    <a:masterClrMapping/>
+  </p:clrMapOvr>
+</p:sld>
+</file>
+
+<file path=ppt/slides/slide14.xml><?xml version="1.0" encoding="utf-8"?>
+<p:sld xmlns:a="http://schemas.openxmlformats.org/drawingml/2006/main" xmlns:r="http://schemas.openxmlformats.org/officeDocument/2006/relationships" xmlns:p="http://schemas.openxmlformats.org/presentationml/2006/main">
+  <p:cSld>
+    <p:spTree>
+      <p:nvGrpSpPr>
+        <p:cNvPr id="1" name="">
+          <a:extLst>
+            <a:ext uri="{FF2B5EF4-FFF2-40B4-BE49-F238E27FC236}">
+              <a16:creationId xmlns:a16="http://schemas.microsoft.com/office/drawing/2014/main" id="{E3D339BF-3FE3-EB00-C401-10099B5660E9}"/>
+            </a:ext>
+          </a:extLst>
+        </p:cNvPr>
+        <p:cNvGrpSpPr/>
+        <p:nvPr/>
+      </p:nvGrpSpPr>
+      <p:grpSpPr>
+        <a:xfrm>
+          <a:off x="0" y="0"/>
+          <a:ext cx="0" cy="0"/>
+          <a:chOff x="0" y="0"/>
+          <a:chExt cx="0" cy="0"/>
+        </a:xfrm>
+      </p:grpSpPr>
+      <p:sp>
+        <p:nvSpPr>
+          <p:cNvPr id="3" name="TextBox 2">
+            <a:extLst>
+              <a:ext uri="{FF2B5EF4-FFF2-40B4-BE49-F238E27FC236}">
+                <a16:creationId xmlns:a16="http://schemas.microsoft.com/office/drawing/2014/main" id="{086DFF72-6659-8A85-3090-BB09FCE77D64}"/>
+              </a:ext>
+            </a:extLst>
+          </p:cNvPr>
+          <p:cNvSpPr txBox="1"/>
+          <p:nvPr/>
+        </p:nvSpPr>
+        <p:spPr>
+          <a:xfrm>
+            <a:off x="217714" y="255046"/>
+            <a:ext cx="11756571" cy="355354"/>
+          </a:xfrm>
+          <a:prstGeom prst="rect">
+            <a:avLst/>
+          </a:prstGeom>
+          <a:noFill/>
+        </p:spPr>
+        <p:txBody>
+          <a:bodyPr wrap="square">
+            <a:spAutoFit/>
+          </a:bodyPr>
+          <a:lstStyle/>
+          <a:p>
+            <a:pPr>
+              <a:lnSpc>
+                <a:spcPct val="150000"/>
+              </a:lnSpc>
+              <a:buNone/>
+            </a:pPr>
+            <a:r>
+              <a:rPr kumimoji="0" lang="en-US" altLang="en-US" sz="1300" b="0" i="0" u="none" strike="noStrike" cap="none" normalizeH="0" baseline="0">
+                <a:ln>
+                  <a:noFill/>
+                </a:ln>
+                <a:solidFill>
+                  <a:schemeClr val="tx1"/>
+                </a:solidFill>
+                <a:effectLst/>
+                <a:latin typeface="Arial" panose="020B0604020202020204" pitchFamily="34" charset="0"/>
+              </a:rPr>
+              <a:t>.</a:t>
+            </a:r>
+          </a:p>
+        </p:txBody>
+      </p:sp>
+    </p:spTree>
+    <p:extLst>
+      <p:ext uri="{BB962C8B-B14F-4D97-AF65-F5344CB8AC3E}">
+        <p14:creationId xmlns:p14="http://schemas.microsoft.com/office/powerpoint/2010/main" val="289256986"/>
+      </p:ext>
+    </p:extLst>
+  </p:cSld>
+  <p:clrMapOvr>
+    <a:masterClrMapping/>
+  </p:clrMapOvr>
+</p:sld>
+</file>
+
+<file path=ppt/slides/slide15.xml><?xml version="1.0" encoding="utf-8"?>
+<p:sld xmlns:a="http://schemas.openxmlformats.org/drawingml/2006/main" xmlns:r="http://schemas.openxmlformats.org/officeDocument/2006/relationships" xmlns:p="http://schemas.openxmlformats.org/presentationml/2006/main">
+  <p:cSld>
+    <p:spTree>
+      <p:nvGrpSpPr>
+        <p:cNvPr id="1" name="">
+          <a:extLst>
+            <a:ext uri="{FF2B5EF4-FFF2-40B4-BE49-F238E27FC236}">
+              <a16:creationId xmlns:a16="http://schemas.microsoft.com/office/drawing/2014/main" id="{ECE25D7D-A080-F22B-7E8D-36EC827289A1}"/>
+            </a:ext>
+          </a:extLst>
+        </p:cNvPr>
+        <p:cNvGrpSpPr/>
+        <p:nvPr/>
+      </p:nvGrpSpPr>
+      <p:grpSpPr>
+        <a:xfrm>
+          <a:off x="0" y="0"/>
+          <a:ext cx="0" cy="0"/>
+          <a:chOff x="0" y="0"/>
+          <a:chExt cx="0" cy="0"/>
+        </a:xfrm>
+      </p:grpSpPr>
+      <p:sp>
+        <p:nvSpPr>
+          <p:cNvPr id="3" name="TextBox 2">
+            <a:extLst>
+              <a:ext uri="{FF2B5EF4-FFF2-40B4-BE49-F238E27FC236}">
+                <a16:creationId xmlns:a16="http://schemas.microsoft.com/office/drawing/2014/main" id="{E33F16A3-A6E8-401E-847B-09570DC6E4CB}"/>
+              </a:ext>
+            </a:extLst>
+          </p:cNvPr>
+          <p:cNvSpPr txBox="1"/>
+          <p:nvPr/>
+        </p:nvSpPr>
+        <p:spPr>
+          <a:xfrm>
+            <a:off x="217714" y="255046"/>
+            <a:ext cx="11756571" cy="355354"/>
+          </a:xfrm>
+          <a:prstGeom prst="rect">
+            <a:avLst/>
+          </a:prstGeom>
+          <a:noFill/>
+        </p:spPr>
+        <p:txBody>
+          <a:bodyPr wrap="square">
+            <a:spAutoFit/>
+          </a:bodyPr>
+          <a:lstStyle/>
+          <a:p>
+            <a:pPr>
+              <a:lnSpc>
+                <a:spcPct val="150000"/>
+              </a:lnSpc>
+              <a:buNone/>
+            </a:pPr>
+            <a:r>
+              <a:rPr kumimoji="0" lang="en-US" altLang="en-US" sz="1300" b="0" i="0" u="none" strike="noStrike" cap="none" normalizeH="0" baseline="0">
+                <a:ln>
+                  <a:noFill/>
+                </a:ln>
+                <a:solidFill>
+                  <a:schemeClr val="tx1"/>
+                </a:solidFill>
+                <a:effectLst/>
+                <a:latin typeface="Arial" panose="020B0604020202020204" pitchFamily="34" charset="0"/>
+              </a:rPr>
+              <a:t>.</a:t>
+            </a:r>
+          </a:p>
+        </p:txBody>
+      </p:sp>
+    </p:spTree>
+    <p:extLst>
+      <p:ext uri="{BB962C8B-B14F-4D97-AF65-F5344CB8AC3E}">
+        <p14:creationId xmlns:p14="http://schemas.microsoft.com/office/powerpoint/2010/main" val="3095838342"/>
+      </p:ext>
+    </p:extLst>
+  </p:cSld>
+  <p:clrMapOvr>
+    <a:masterClrMapping/>
+  </p:clrMapOvr>
+</p:sld>
+</file>
+
 <file path=ppt/slides/slide2.xml><?xml version="1.0" encoding="utf-8"?>
+<p:sld xmlns:a="http://schemas.openxmlformats.org/drawingml/2006/main" xmlns:r="http://schemas.openxmlformats.org/officeDocument/2006/relationships" xmlns:p="http://schemas.openxmlformats.org/presentationml/2006/main">
+  <p:cSld>
+    <p:spTree>
+      <p:nvGrpSpPr>
+        <p:cNvPr id="1" name="">
+          <a:extLst>
+            <a:ext uri="{FF2B5EF4-FFF2-40B4-BE49-F238E27FC236}">
+              <a16:creationId xmlns:a16="http://schemas.microsoft.com/office/drawing/2014/main" id="{3E65AFA8-CC98-D3BE-E7E1-7ABD883EF1C1}"/>
+            </a:ext>
+          </a:extLst>
+        </p:cNvPr>
+        <p:cNvGrpSpPr/>
+        <p:nvPr/>
+      </p:nvGrpSpPr>
+      <p:grpSpPr>
+        <a:xfrm>
+          <a:off x="0" y="0"/>
+          <a:ext cx="0" cy="0"/>
+          <a:chOff x="0" y="0"/>
+          <a:chExt cx="0" cy="0"/>
+        </a:xfrm>
+      </p:grpSpPr>
+      <p:sp>
+        <p:nvSpPr>
+          <p:cNvPr id="3" name="TextBox 2">
+            <a:extLst>
+              <a:ext uri="{FF2B5EF4-FFF2-40B4-BE49-F238E27FC236}">
+                <a16:creationId xmlns:a16="http://schemas.microsoft.com/office/drawing/2014/main" id="{904CD79A-95DD-A87D-5C43-469A416E3A1D}"/>
+              </a:ext>
+            </a:extLst>
+          </p:cNvPr>
+          <p:cNvSpPr txBox="1"/>
+          <p:nvPr/>
+        </p:nvSpPr>
+        <p:spPr>
+          <a:xfrm>
+            <a:off x="217714" y="255046"/>
+            <a:ext cx="11756571" cy="355354"/>
+          </a:xfrm>
+          <a:prstGeom prst="rect">
+            <a:avLst/>
+          </a:prstGeom>
+          <a:noFill/>
+        </p:spPr>
+        <p:txBody>
+          <a:bodyPr wrap="square">
+            <a:spAutoFit/>
+          </a:bodyPr>
+          <a:lstStyle/>
+          <a:p>
+            <a:pPr>
+              <a:lnSpc>
+                <a:spcPct val="150000"/>
+              </a:lnSpc>
+              <a:buNone/>
+            </a:pPr>
+            <a:r>
+              <a:rPr lang="en-US" altLang="en-US" sz="1300">
+                <a:latin typeface="Arial" panose="020B0604020202020204" pitchFamily="34" charset="0"/>
+              </a:rPr>
+              <a:t>app\Http\Controllers\Backend\ProductController.php</a:t>
+            </a:r>
+            <a:r>
+              <a:rPr lang="az-Latn-AZ" altLang="en-US" sz="1300">
+                <a:latin typeface="Arial" panose="020B0604020202020204" pitchFamily="34" charset="0"/>
+              </a:rPr>
+              <a:t> - İmageUploadTrait əlavə edirik.</a:t>
+            </a:r>
+            <a:endParaRPr kumimoji="0" lang="en-US" altLang="en-US" sz="1300" b="0" i="0" u="none" strike="noStrike" cap="none" normalizeH="0" baseline="0">
+              <a:ln>
+                <a:noFill/>
+              </a:ln>
+              <a:solidFill>
+                <a:schemeClr val="tx1"/>
+              </a:solidFill>
+              <a:effectLst/>
+              <a:latin typeface="Arial" panose="020B0604020202020204" pitchFamily="34" charset="0"/>
+            </a:endParaRPr>
+          </a:p>
+        </p:txBody>
+      </p:sp>
+      <p:pic>
+        <p:nvPicPr>
+          <p:cNvPr id="4" name="Picture 3">
+            <a:extLst>
+              <a:ext uri="{FF2B5EF4-FFF2-40B4-BE49-F238E27FC236}">
+                <a16:creationId xmlns:a16="http://schemas.microsoft.com/office/drawing/2014/main" id="{BC11224A-B459-A8E2-933A-60D5BD2D42F2}"/>
+              </a:ext>
+            </a:extLst>
+          </p:cNvPr>
+          <p:cNvPicPr>
+            <a:picLocks noChangeAspect="1"/>
+          </p:cNvPicPr>
+          <p:nvPr/>
+        </p:nvPicPr>
+        <p:blipFill>
+          <a:blip r:embed="rId2"/>
+          <a:stretch>
+            <a:fillRect/>
+          </a:stretch>
+        </p:blipFill>
+        <p:spPr>
+          <a:xfrm>
+            <a:off x="8219722" y="0"/>
+            <a:ext cx="3972278" cy="6858000"/>
+          </a:xfrm>
+          <a:prstGeom prst="rect">
+            <a:avLst/>
+          </a:prstGeom>
+        </p:spPr>
+      </p:pic>
+    </p:spTree>
+    <p:extLst>
+      <p:ext uri="{BB962C8B-B14F-4D97-AF65-F5344CB8AC3E}">
+        <p14:creationId xmlns:p14="http://schemas.microsoft.com/office/powerpoint/2010/main" val="265821999"/>
+      </p:ext>
+    </p:extLst>
+  </p:cSld>
+  <p:clrMapOvr>
+    <a:masterClrMapping/>
+  </p:clrMapOvr>
+</p:sld>
+</file>
+
+<file path=ppt/slides/slide3.xml><?xml version="1.0" encoding="utf-8"?>
+<p:sld xmlns:a="http://schemas.openxmlformats.org/drawingml/2006/main" xmlns:r="http://schemas.openxmlformats.org/officeDocument/2006/relationships" xmlns:p="http://schemas.openxmlformats.org/presentationml/2006/main">
+  <p:cSld>
+    <p:spTree>
+      <p:nvGrpSpPr>
+        <p:cNvPr id="1" name="">
+          <a:extLst>
+            <a:ext uri="{FF2B5EF4-FFF2-40B4-BE49-F238E27FC236}">
+              <a16:creationId xmlns:a16="http://schemas.microsoft.com/office/drawing/2014/main" id="{4DDB533A-CE19-1A91-7A85-F148F009447F}"/>
+            </a:ext>
+          </a:extLst>
+        </p:cNvPr>
+        <p:cNvGrpSpPr/>
+        <p:nvPr/>
+      </p:nvGrpSpPr>
+      <p:grpSpPr>
+        <a:xfrm>
+          <a:off x="0" y="0"/>
+          <a:ext cx="0" cy="0"/>
+          <a:chOff x="0" y="0"/>
+          <a:chExt cx="0" cy="0"/>
+        </a:xfrm>
+      </p:grpSpPr>
+      <p:sp>
+        <p:nvSpPr>
+          <p:cNvPr id="3" name="TextBox 2">
+            <a:extLst>
+              <a:ext uri="{FF2B5EF4-FFF2-40B4-BE49-F238E27FC236}">
+                <a16:creationId xmlns:a16="http://schemas.microsoft.com/office/drawing/2014/main" id="{9DD567A2-E77D-E32D-4C5F-CD718D915B4A}"/>
+              </a:ext>
+            </a:extLst>
+          </p:cNvPr>
+          <p:cNvSpPr txBox="1"/>
+          <p:nvPr/>
+        </p:nvSpPr>
+        <p:spPr>
+          <a:xfrm>
+            <a:off x="217714" y="255046"/>
+            <a:ext cx="11756571" cy="355354"/>
+          </a:xfrm>
+          <a:prstGeom prst="rect">
+            <a:avLst/>
+          </a:prstGeom>
+          <a:noFill/>
+        </p:spPr>
+        <p:txBody>
+          <a:bodyPr wrap="square">
+            <a:spAutoFit/>
+          </a:bodyPr>
+          <a:lstStyle/>
+          <a:p>
+            <a:pPr>
+              <a:lnSpc>
+                <a:spcPct val="150000"/>
+              </a:lnSpc>
+              <a:buNone/>
+            </a:pPr>
+            <a:r>
+              <a:rPr kumimoji="0" lang="az-Latn-AZ" altLang="en-US" sz="1300" b="0" i="0" u="none" strike="noStrike" cap="none" normalizeH="0" baseline="0">
+                <a:ln>
+                  <a:noFill/>
+                </a:ln>
+                <a:solidFill>
+                  <a:schemeClr val="tx1"/>
+                </a:solidFill>
+                <a:effectLst/>
+                <a:latin typeface="Arial" panose="020B0604020202020204" pitchFamily="34" charset="0"/>
+              </a:rPr>
+              <a:t>Test üçün 2 dənə brand adı əlavə edək.</a:t>
+            </a:r>
+            <a:endParaRPr kumimoji="0" lang="en-US" altLang="en-US" sz="1300" b="0" i="0" u="none" strike="noStrike" cap="none" normalizeH="0" baseline="0">
+              <a:ln>
+                <a:noFill/>
+              </a:ln>
+              <a:solidFill>
+                <a:schemeClr val="tx1"/>
+              </a:solidFill>
+              <a:effectLst/>
+              <a:latin typeface="Arial" panose="020B0604020202020204" pitchFamily="34" charset="0"/>
+            </a:endParaRPr>
+          </a:p>
+        </p:txBody>
+      </p:sp>
+      <p:pic>
+        <p:nvPicPr>
+          <p:cNvPr id="4" name="Picture 3">
+            <a:extLst>
+              <a:ext uri="{FF2B5EF4-FFF2-40B4-BE49-F238E27FC236}">
+                <a16:creationId xmlns:a16="http://schemas.microsoft.com/office/drawing/2014/main" id="{F143112D-484E-59B5-1105-3552154974AB}"/>
+              </a:ext>
+            </a:extLst>
+          </p:cNvPr>
+          <p:cNvPicPr>
+            <a:picLocks noChangeAspect="1"/>
+          </p:cNvPicPr>
+          <p:nvPr/>
+        </p:nvPicPr>
+        <p:blipFill>
+          <a:blip r:embed="rId2"/>
+          <a:stretch>
+            <a:fillRect/>
+          </a:stretch>
+        </p:blipFill>
+        <p:spPr>
+          <a:xfrm>
+            <a:off x="0" y="2240604"/>
+            <a:ext cx="12192000" cy="4617396"/>
+          </a:xfrm>
+          <a:prstGeom prst="rect">
+            <a:avLst/>
+          </a:prstGeom>
+        </p:spPr>
+      </p:pic>
+    </p:spTree>
+    <p:extLst>
+      <p:ext uri="{BB962C8B-B14F-4D97-AF65-F5344CB8AC3E}">
+        <p14:creationId xmlns:p14="http://schemas.microsoft.com/office/powerpoint/2010/main" val="252457358"/>
+      </p:ext>
+    </p:extLst>
+  </p:cSld>
+  <p:clrMapOvr>
+    <a:masterClrMapping/>
+  </p:clrMapOvr>
+</p:sld>
+</file>
+
+<file path=ppt/slides/slide4.xml><?xml version="1.0" encoding="utf-8"?>
+<p:sld xmlns:a="http://schemas.openxmlformats.org/drawingml/2006/main" xmlns:r="http://schemas.openxmlformats.org/officeDocument/2006/relationships" xmlns:p="http://schemas.openxmlformats.org/presentationml/2006/main">
+  <p:cSld>
+    <p:spTree>
+      <p:nvGrpSpPr>
+        <p:cNvPr id="1" name="">
+          <a:extLst>
+            <a:ext uri="{FF2B5EF4-FFF2-40B4-BE49-F238E27FC236}">
+              <a16:creationId xmlns:a16="http://schemas.microsoft.com/office/drawing/2014/main" id="{BF92C6B5-D2AE-79E3-3333-68E9DC55B2F5}"/>
+            </a:ext>
+          </a:extLst>
+        </p:cNvPr>
+        <p:cNvGrpSpPr/>
+        <p:nvPr/>
+      </p:nvGrpSpPr>
+      <p:grpSpPr>
+        <a:xfrm>
+          <a:off x="0" y="0"/>
+          <a:ext cx="0" cy="0"/>
+          <a:chOff x="0" y="0"/>
+          <a:chExt cx="0" cy="0"/>
+        </a:xfrm>
+      </p:grpSpPr>
+      <p:sp>
+        <p:nvSpPr>
+          <p:cNvPr id="3" name="TextBox 2">
+            <a:extLst>
+              <a:ext uri="{FF2B5EF4-FFF2-40B4-BE49-F238E27FC236}">
+                <a16:creationId xmlns:a16="http://schemas.microsoft.com/office/drawing/2014/main" id="{A4CF3202-ACC1-256F-7AE5-A49753213F7A}"/>
+              </a:ext>
+            </a:extLst>
+          </p:cNvPr>
+          <p:cNvSpPr txBox="1"/>
+          <p:nvPr/>
+        </p:nvSpPr>
+        <p:spPr>
+          <a:xfrm>
+            <a:off x="217715" y="255046"/>
+            <a:ext cx="8275122" cy="1255600"/>
+          </a:xfrm>
+          <a:prstGeom prst="rect">
+            <a:avLst/>
+          </a:prstGeom>
+          <a:noFill/>
+        </p:spPr>
+        <p:txBody>
+          <a:bodyPr wrap="square">
+            <a:spAutoFit/>
+          </a:bodyPr>
+          <a:lstStyle/>
+          <a:p>
+            <a:pPr>
+              <a:lnSpc>
+                <a:spcPct val="150000"/>
+              </a:lnSpc>
+              <a:buNone/>
+            </a:pPr>
+            <a:r>
+              <a:rPr lang="az-Latn-AZ" altLang="en-US" sz="1300">
+                <a:latin typeface="Arial" panose="020B0604020202020204" pitchFamily="34" charset="0"/>
+              </a:rPr>
+              <a:t>app\Http\Controllers\Backend\ProductController.php</a:t>
+            </a:r>
+          </a:p>
+          <a:p>
+            <a:pPr>
+              <a:lnSpc>
+                <a:spcPct val="150000"/>
+              </a:lnSpc>
+              <a:buNone/>
+            </a:pPr>
+            <a:endParaRPr lang="az-Latn-AZ" altLang="en-US" sz="1300">
+              <a:latin typeface="Arial" panose="020B0604020202020204" pitchFamily="34" charset="0"/>
+            </a:endParaRPr>
+          </a:p>
+          <a:p>
+            <a:pPr>
+              <a:lnSpc>
+                <a:spcPct val="150000"/>
+              </a:lnSpc>
+              <a:buNone/>
+            </a:pPr>
+            <a:endParaRPr lang="az-Latn-AZ" altLang="en-US" sz="1300">
+              <a:latin typeface="Arial" panose="020B0604020202020204" pitchFamily="34" charset="0"/>
+            </a:endParaRPr>
+          </a:p>
+          <a:p>
+            <a:pPr>
+              <a:lnSpc>
+                <a:spcPct val="150000"/>
+              </a:lnSpc>
+              <a:buNone/>
+            </a:pPr>
+            <a:r>
+              <a:rPr lang="az-Latn-AZ" altLang="en-US" sz="1300" b="1">
+                <a:latin typeface="Arial" panose="020B0604020202020204" pitchFamily="34" charset="0"/>
+              </a:rPr>
+              <a:t>product</a:t>
+            </a:r>
+            <a:r>
+              <a:rPr lang="az-Latn-AZ" altLang="en-US" sz="1300">
+                <a:latin typeface="Arial" panose="020B0604020202020204" pitchFamily="34" charset="0"/>
+              </a:rPr>
+              <a:t> -u əlavə etmək üçün yazdığımız </a:t>
+            </a:r>
+            <a:r>
+              <a:rPr lang="az-Latn-AZ" altLang="en-US" sz="1300" b="1">
+                <a:latin typeface="Arial" panose="020B0604020202020204" pitchFamily="34" charset="0"/>
+              </a:rPr>
+              <a:t>store() </a:t>
+            </a:r>
+            <a:r>
+              <a:rPr lang="az-Latn-AZ" altLang="en-US" sz="1300">
+                <a:latin typeface="Arial" panose="020B0604020202020204" pitchFamily="34" charset="0"/>
+              </a:rPr>
+              <a:t>metodu.</a:t>
+            </a:r>
+            <a:endParaRPr kumimoji="0" lang="en-US" altLang="en-US" sz="1300" b="0" i="0" u="none" strike="noStrike" cap="none" normalizeH="0" baseline="0">
+              <a:ln>
+                <a:noFill/>
+              </a:ln>
+              <a:solidFill>
+                <a:schemeClr val="tx1"/>
+              </a:solidFill>
+              <a:effectLst/>
+              <a:latin typeface="Arial" panose="020B0604020202020204" pitchFamily="34" charset="0"/>
+            </a:endParaRPr>
+          </a:p>
+        </p:txBody>
+      </p:sp>
+      <p:pic>
+        <p:nvPicPr>
+          <p:cNvPr id="4" name="Picture 3">
+            <a:extLst>
+              <a:ext uri="{FF2B5EF4-FFF2-40B4-BE49-F238E27FC236}">
+                <a16:creationId xmlns:a16="http://schemas.microsoft.com/office/drawing/2014/main" id="{08E750C0-A52A-5BB2-57E1-1E36BBA55AC1}"/>
+              </a:ext>
+            </a:extLst>
+          </p:cNvPr>
+          <p:cNvPicPr>
+            <a:picLocks noChangeAspect="1"/>
+          </p:cNvPicPr>
+          <p:nvPr/>
+        </p:nvPicPr>
+        <p:blipFill>
+          <a:blip r:embed="rId2"/>
+          <a:stretch>
+            <a:fillRect/>
+          </a:stretch>
+        </p:blipFill>
+        <p:spPr>
+          <a:xfrm>
+            <a:off x="8492836" y="0"/>
+            <a:ext cx="3699164" cy="6858000"/>
+          </a:xfrm>
+          <a:prstGeom prst="rect">
+            <a:avLst/>
+          </a:prstGeom>
+        </p:spPr>
+      </p:pic>
+    </p:spTree>
+    <p:extLst>
+      <p:ext uri="{BB962C8B-B14F-4D97-AF65-F5344CB8AC3E}">
+        <p14:creationId xmlns:p14="http://schemas.microsoft.com/office/powerpoint/2010/main" val="2441176227"/>
+      </p:ext>
+    </p:extLst>
+  </p:cSld>
+  <p:clrMapOvr>
+    <a:masterClrMapping/>
+  </p:clrMapOvr>
+</p:sld>
+</file>
+
+<file path=ppt/slides/slide5.xml><?xml version="1.0" encoding="utf-8"?>
+<p:sld xmlns:a="http://schemas.openxmlformats.org/drawingml/2006/main" xmlns:r="http://schemas.openxmlformats.org/officeDocument/2006/relationships" xmlns:p="http://schemas.openxmlformats.org/presentationml/2006/main">
+  <p:cSld>
+    <p:spTree>
+      <p:nvGrpSpPr>
+        <p:cNvPr id="1" name="">
+          <a:extLst>
+            <a:ext uri="{FF2B5EF4-FFF2-40B4-BE49-F238E27FC236}">
+              <a16:creationId xmlns:a16="http://schemas.microsoft.com/office/drawing/2014/main" id="{D51D7AB2-CA79-1E92-65BF-42A1F437AEA5}"/>
+            </a:ext>
+          </a:extLst>
+        </p:cNvPr>
+        <p:cNvGrpSpPr/>
+        <p:nvPr/>
+      </p:nvGrpSpPr>
+      <p:grpSpPr>
+        <a:xfrm>
+          <a:off x="0" y="0"/>
+          <a:ext cx="0" cy="0"/>
+          <a:chOff x="0" y="0"/>
+          <a:chExt cx="0" cy="0"/>
+        </a:xfrm>
+      </p:grpSpPr>
+      <p:sp>
+        <p:nvSpPr>
+          <p:cNvPr id="3" name="TextBox 2">
+            <a:extLst>
+              <a:ext uri="{FF2B5EF4-FFF2-40B4-BE49-F238E27FC236}">
+                <a16:creationId xmlns:a16="http://schemas.microsoft.com/office/drawing/2014/main" id="{0112D4D0-59C5-7F8C-54B8-420ED506D61C}"/>
+              </a:ext>
+            </a:extLst>
+          </p:cNvPr>
+          <p:cNvSpPr txBox="1"/>
+          <p:nvPr/>
+        </p:nvSpPr>
+        <p:spPr>
+          <a:xfrm>
+            <a:off x="217714" y="255046"/>
+            <a:ext cx="11756571" cy="355354"/>
+          </a:xfrm>
+          <a:prstGeom prst="rect">
+            <a:avLst/>
+          </a:prstGeom>
+          <a:noFill/>
+        </p:spPr>
+        <p:txBody>
+          <a:bodyPr wrap="square">
+            <a:spAutoFit/>
+          </a:bodyPr>
+          <a:lstStyle/>
+          <a:p>
+            <a:pPr>
+              <a:lnSpc>
+                <a:spcPct val="150000"/>
+              </a:lnSpc>
+              <a:buNone/>
+            </a:pPr>
+            <a:r>
+              <a:rPr lang="az-Latn-AZ" altLang="en-US" sz="1300">
+                <a:latin typeface="Arial" panose="020B0604020202020204" pitchFamily="34" charset="0"/>
+              </a:rPr>
+              <a:t>Sahələri dolduraraq Save düyməsini klikləyirik.</a:t>
+            </a:r>
+            <a:endParaRPr kumimoji="0" lang="en-US" altLang="en-US" sz="1300" b="0" i="0" u="none" strike="noStrike" cap="none" normalizeH="0" baseline="0">
+              <a:ln>
+                <a:noFill/>
+              </a:ln>
+              <a:solidFill>
+                <a:schemeClr val="tx1"/>
+              </a:solidFill>
+              <a:effectLst/>
+              <a:latin typeface="Arial" panose="020B0604020202020204" pitchFamily="34" charset="0"/>
+            </a:endParaRPr>
+          </a:p>
+        </p:txBody>
+      </p:sp>
+      <p:pic>
+        <p:nvPicPr>
+          <p:cNvPr id="4" name="Picture 3">
+            <a:extLst>
+              <a:ext uri="{FF2B5EF4-FFF2-40B4-BE49-F238E27FC236}">
+                <a16:creationId xmlns:a16="http://schemas.microsoft.com/office/drawing/2014/main" id="{8A8E1E78-8243-AB32-F032-0FE14F1F50BB}"/>
+              </a:ext>
+            </a:extLst>
+          </p:cNvPr>
+          <p:cNvPicPr>
+            <a:picLocks noChangeAspect="1"/>
+          </p:cNvPicPr>
+          <p:nvPr/>
+        </p:nvPicPr>
+        <p:blipFill>
+          <a:blip r:embed="rId2"/>
+          <a:stretch>
+            <a:fillRect/>
+          </a:stretch>
+        </p:blipFill>
+        <p:spPr>
+          <a:xfrm>
+            <a:off x="0" y="1737233"/>
+            <a:ext cx="12192000" cy="5120767"/>
+          </a:xfrm>
+          <a:prstGeom prst="rect">
+            <a:avLst/>
+          </a:prstGeom>
+        </p:spPr>
+      </p:pic>
+    </p:spTree>
+    <p:extLst>
+      <p:ext uri="{BB962C8B-B14F-4D97-AF65-F5344CB8AC3E}">
+        <p14:creationId xmlns:p14="http://schemas.microsoft.com/office/powerpoint/2010/main" val="1272295475"/>
+      </p:ext>
+    </p:extLst>
+  </p:cSld>
+  <p:clrMapOvr>
+    <a:masterClrMapping/>
+  </p:clrMapOvr>
+</p:sld>
+</file>
+
+<file path=ppt/slides/slide6.xml><?xml version="1.0" encoding="utf-8"?>
+<p:sld xmlns:a="http://schemas.openxmlformats.org/drawingml/2006/main" xmlns:r="http://schemas.openxmlformats.org/officeDocument/2006/relationships" xmlns:p="http://schemas.openxmlformats.org/presentationml/2006/main">
+  <p:cSld>
+    <p:spTree>
+      <p:nvGrpSpPr>
+        <p:cNvPr id="1" name="">
+          <a:extLst>
+            <a:ext uri="{FF2B5EF4-FFF2-40B4-BE49-F238E27FC236}">
+              <a16:creationId xmlns:a16="http://schemas.microsoft.com/office/drawing/2014/main" id="{B57719BD-F425-C7E6-00B8-EBEA13C1D93C}"/>
+            </a:ext>
+          </a:extLst>
+        </p:cNvPr>
+        <p:cNvGrpSpPr/>
+        <p:nvPr/>
+      </p:nvGrpSpPr>
+      <p:grpSpPr>
+        <a:xfrm>
+          <a:off x="0" y="0"/>
+          <a:ext cx="0" cy="0"/>
+          <a:chOff x="0" y="0"/>
+          <a:chExt cx="0" cy="0"/>
+        </a:xfrm>
+      </p:grpSpPr>
+      <p:sp>
+        <p:nvSpPr>
+          <p:cNvPr id="3" name="TextBox 2">
+            <a:extLst>
+              <a:ext uri="{FF2B5EF4-FFF2-40B4-BE49-F238E27FC236}">
+                <a16:creationId xmlns:a16="http://schemas.microsoft.com/office/drawing/2014/main" id="{33937978-5171-3129-843E-A7E799DF5C2A}"/>
+              </a:ext>
+            </a:extLst>
+          </p:cNvPr>
+          <p:cNvSpPr txBox="1"/>
+          <p:nvPr/>
+        </p:nvSpPr>
+        <p:spPr>
+          <a:xfrm>
+            <a:off x="217714" y="255046"/>
+            <a:ext cx="11756571" cy="355354"/>
+          </a:xfrm>
+          <a:prstGeom prst="rect">
+            <a:avLst/>
+          </a:prstGeom>
+          <a:noFill/>
+        </p:spPr>
+        <p:txBody>
+          <a:bodyPr wrap="square">
+            <a:spAutoFit/>
+          </a:bodyPr>
+          <a:lstStyle/>
+          <a:p>
+            <a:pPr>
+              <a:lnSpc>
+                <a:spcPct val="150000"/>
+              </a:lnSpc>
+              <a:buNone/>
+            </a:pPr>
+            <a:r>
+              <a:rPr lang="az-Latn-AZ" altLang="en-US" sz="1300">
+                <a:latin typeface="Arial" panose="020B0604020202020204" pitchFamily="34" charset="0"/>
+              </a:rPr>
+              <a:t>product əlavə edildi.</a:t>
+            </a:r>
+            <a:endParaRPr kumimoji="0" lang="en-US" altLang="en-US" sz="1300" b="0" i="0" u="none" strike="noStrike" cap="none" normalizeH="0" baseline="0">
+              <a:ln>
+                <a:noFill/>
+              </a:ln>
+              <a:solidFill>
+                <a:schemeClr val="tx1"/>
+              </a:solidFill>
+              <a:effectLst/>
+              <a:latin typeface="Arial" panose="020B0604020202020204" pitchFamily="34" charset="0"/>
+            </a:endParaRPr>
+          </a:p>
+        </p:txBody>
+      </p:sp>
+      <p:pic>
+        <p:nvPicPr>
+          <p:cNvPr id="6" name="Picture 5">
+            <a:extLst>
+              <a:ext uri="{FF2B5EF4-FFF2-40B4-BE49-F238E27FC236}">
+                <a16:creationId xmlns:a16="http://schemas.microsoft.com/office/drawing/2014/main" id="{71ADC3AA-A3F3-DC1D-9C3A-6E96F7C71015}"/>
+              </a:ext>
+            </a:extLst>
+          </p:cNvPr>
+          <p:cNvPicPr>
+            <a:picLocks noChangeAspect="1"/>
+          </p:cNvPicPr>
+          <p:nvPr/>
+        </p:nvPicPr>
+        <p:blipFill>
+          <a:blip r:embed="rId2"/>
+          <a:stretch>
+            <a:fillRect/>
+          </a:stretch>
+        </p:blipFill>
+        <p:spPr>
+          <a:xfrm>
+            <a:off x="0" y="3128608"/>
+            <a:ext cx="12192000" cy="3729392"/>
+          </a:xfrm>
+          <a:prstGeom prst="rect">
+            <a:avLst/>
+          </a:prstGeom>
+        </p:spPr>
+      </p:pic>
+    </p:spTree>
+    <p:extLst>
+      <p:ext uri="{BB962C8B-B14F-4D97-AF65-F5344CB8AC3E}">
+        <p14:creationId xmlns:p14="http://schemas.microsoft.com/office/powerpoint/2010/main" val="3566762105"/>
+      </p:ext>
+    </p:extLst>
+  </p:cSld>
+  <p:clrMapOvr>
+    <a:masterClrMapping/>
+  </p:clrMapOvr>
+</p:sld>
+</file>
+
+<file path=ppt/slides/slide7.xml><?xml version="1.0" encoding="utf-8"?>
 <p:sld xmlns:a="http://schemas.openxmlformats.org/drawingml/2006/main" xmlns:r="http://schemas.openxmlformats.org/officeDocument/2006/relationships" xmlns:p="http://schemas.openxmlformats.org/presentationml/2006/main">
   <p:cSld>
     <p:spTree>
@@ -3455,21 +4702,68 @@
               <a:buNone/>
             </a:pPr>
             <a:r>
-              <a:rPr kumimoji="0" lang="en-US" altLang="en-US" sz="1300" b="0" i="0" u="none" strike="noStrike" cap="none" normalizeH="0" baseline="0">
-                <a:ln>
-                  <a:noFill/>
-                </a:ln>
-                <a:solidFill>
-                  <a:schemeClr val="tx1"/>
-                </a:solidFill>
-                <a:effectLst/>
+              <a:rPr lang="az-Latn-AZ" altLang="en-US" sz="1300">
                 <a:latin typeface="Arial" panose="020B0604020202020204" pitchFamily="34" charset="0"/>
               </a:rPr>
-              <a:t>.</a:t>
-            </a:r>
-          </a:p>
-        </p:txBody>
-      </p:sp>
+              <a:t>Həmin əlavə etdiyimiz product DB -də də görünür.</a:t>
+            </a:r>
+            <a:endParaRPr kumimoji="0" lang="en-US" altLang="en-US" sz="1300" b="0" i="0" u="none" strike="noStrike" cap="none" normalizeH="0" baseline="0">
+              <a:ln>
+                <a:noFill/>
+              </a:ln>
+              <a:solidFill>
+                <a:schemeClr val="tx1"/>
+              </a:solidFill>
+              <a:effectLst/>
+              <a:latin typeface="Arial" panose="020B0604020202020204" pitchFamily="34" charset="0"/>
+            </a:endParaRPr>
+          </a:p>
+        </p:txBody>
+      </p:sp>
+      <p:pic>
+        <p:nvPicPr>
+          <p:cNvPr id="4" name="Picture 3">
+            <a:extLst>
+              <a:ext uri="{FF2B5EF4-FFF2-40B4-BE49-F238E27FC236}">
+                <a16:creationId xmlns:a16="http://schemas.microsoft.com/office/drawing/2014/main" id="{6075F0AA-E3F7-C4A0-C0FF-CA389107BCAF}"/>
+              </a:ext>
+            </a:extLst>
+          </p:cNvPr>
+          <p:cNvPicPr>
+            <a:picLocks noChangeAspect="1"/>
+          </p:cNvPicPr>
+          <p:nvPr/>
+        </p:nvPicPr>
+        <p:blipFill>
+          <a:blip r:embed="rId2"/>
+          <a:stretch>
+            <a:fillRect/>
+          </a:stretch>
+        </p:blipFill>
+        <p:spPr>
+          <a:xfrm>
+            <a:off x="-1" y="4716935"/>
+            <a:ext cx="12192000" cy="2141065"/>
+          </a:xfrm>
+          <a:prstGeom prst="rect">
+            <a:avLst/>
+          </a:prstGeom>
+          <a:ln w="38100" cap="sq">
+            <a:solidFill>
+              <a:srgbClr val="000000"/>
+            </a:solidFill>
+            <a:prstDash val="solid"/>
+            <a:miter lim="800000"/>
+          </a:ln>
+          <a:effectLst>
+            <a:outerShdw blurRad="50800" dist="38100" dir="2700000" algn="tl" rotWithShape="0">
+              <a:srgbClr val="000000">
+                <a:alpha val="43000"/>
+              </a:srgbClr>
+            </a:outerShdw>
+          </a:effectLst>
+        </p:spPr>
+      </p:pic>
     </p:spTree>
     <p:extLst>
       <p:ext uri="{BB962C8B-B14F-4D97-AF65-F5344CB8AC3E}">
@@ -3483,7 +4777,7 @@
 </p:sld>
 </file>
 
-<file path=ppt/slides/slide3.xml><?xml version="1.0" encoding="utf-8"?>
+<file path=ppt/slides/slide8.xml><?xml version="1.0" encoding="utf-8"?>
 <p:sld xmlns:a="http://schemas.openxmlformats.org/drawingml/2006/main" xmlns:r="http://schemas.openxmlformats.org/officeDocument/2006/relationships" xmlns:p="http://schemas.openxmlformats.org/presentationml/2006/main">
   <p:cSld>
     <p:spTree>
@@ -3491,7 +4785,7 @@
         <p:cNvPr id="1" name="">
           <a:extLst>
             <a:ext uri="{FF2B5EF4-FFF2-40B4-BE49-F238E27FC236}">
-              <a16:creationId xmlns:a16="http://schemas.microsoft.com/office/drawing/2014/main" id="{ECE25D7D-A080-F22B-7E8D-36EC827289A1}"/>
+              <a16:creationId xmlns:a16="http://schemas.microsoft.com/office/drawing/2014/main" id="{EEC91C71-B5C0-BD4D-7F5C-ED5DCFE7D376}"/>
             </a:ext>
           </a:extLst>
         </p:cNvPr>
@@ -3511,7 +4805,275 @@
           <p:cNvPr id="3" name="TextBox 2">
             <a:extLst>
               <a:ext uri="{FF2B5EF4-FFF2-40B4-BE49-F238E27FC236}">
-                <a16:creationId xmlns:a16="http://schemas.microsoft.com/office/drawing/2014/main" id="{E33F16A3-A6E8-401E-847B-09570DC6E4CB}"/>
+                <a16:creationId xmlns:a16="http://schemas.microsoft.com/office/drawing/2014/main" id="{4EF7AB92-28B0-4CE3-2817-879639942AC9}"/>
+              </a:ext>
+            </a:extLst>
+          </p:cNvPr>
+          <p:cNvSpPr txBox="1"/>
+          <p:nvPr/>
+        </p:nvSpPr>
+        <p:spPr>
+          <a:xfrm>
+            <a:off x="217715" y="255046"/>
+            <a:ext cx="4769922" cy="3056093"/>
+          </a:xfrm>
+          <a:prstGeom prst="rect">
+            <a:avLst/>
+          </a:prstGeom>
+          <a:noFill/>
+        </p:spPr>
+        <p:txBody>
+          <a:bodyPr wrap="square">
+            <a:spAutoFit/>
+          </a:bodyPr>
+          <a:lstStyle/>
+          <a:p>
+            <a:pPr>
+              <a:lnSpc>
+                <a:spcPct val="150000"/>
+              </a:lnSpc>
+              <a:buNone/>
+            </a:pPr>
+            <a:r>
+              <a:rPr kumimoji="0" lang="az-Latn-AZ" altLang="en-US" sz="1300" b="0" i="0" u="none" strike="noStrike" cap="none" normalizeH="0" baseline="0">
+                <a:ln>
+                  <a:noFill/>
+                </a:ln>
+                <a:solidFill>
+                  <a:schemeClr val="tx1"/>
+                </a:solidFill>
+                <a:effectLst/>
+                <a:latin typeface="Arial" panose="020B0604020202020204" pitchFamily="34" charset="0"/>
+              </a:rPr>
+              <a:t>cədvəldə olan sütun adları. </a:t>
+            </a:r>
+          </a:p>
+          <a:p>
+            <a:pPr>
+              <a:lnSpc>
+                <a:spcPct val="150000"/>
+              </a:lnSpc>
+              <a:buNone/>
+            </a:pPr>
+            <a:endParaRPr lang="az-Latn-AZ" altLang="en-US" sz="1300">
+              <a:latin typeface="Arial" panose="020B0604020202020204" pitchFamily="34" charset="0"/>
+            </a:endParaRPr>
+          </a:p>
+          <a:p>
+            <a:pPr>
+              <a:lnSpc>
+                <a:spcPct val="150000"/>
+              </a:lnSpc>
+              <a:buNone/>
+            </a:pPr>
+            <a:r>
+              <a:rPr kumimoji="0" lang="az-Latn-AZ" altLang="en-US" sz="1300" b="0" i="0" u="none" strike="noStrike" cap="none" normalizeH="0" baseline="0">
+                <a:ln>
+                  <a:noFill/>
+                </a:ln>
+                <a:solidFill>
+                  <a:schemeClr val="tx1"/>
+                </a:solidFill>
+                <a:effectLst/>
+                <a:latin typeface="Arial" panose="020B0604020202020204" pitchFamily="34" charset="0"/>
+              </a:rPr>
+              <a:t>Hansı sütuna hardan data </a:t>
+            </a:r>
+            <a:r>
+              <a:rPr lang="az-Latn-AZ" altLang="en-US" sz="1300">
+                <a:latin typeface="Arial" panose="020B0604020202020204" pitchFamily="34" charset="0"/>
+              </a:rPr>
+              <a:t>gedir onu göstərmək üçün əlavə </a:t>
+            </a:r>
+          </a:p>
+          <a:p>
+            <a:pPr>
+              <a:lnSpc>
+                <a:spcPct val="150000"/>
+              </a:lnSpc>
+              <a:buNone/>
+            </a:pPr>
+            <a:r>
+              <a:rPr lang="az-Latn-AZ" altLang="en-US" sz="1300">
+                <a:latin typeface="Arial" panose="020B0604020202020204" pitchFamily="34" charset="0"/>
+              </a:rPr>
+              <a:t>edilən bir şəkildir bu.</a:t>
+            </a:r>
+          </a:p>
+          <a:p>
+            <a:pPr>
+              <a:lnSpc>
+                <a:spcPct val="150000"/>
+              </a:lnSpc>
+              <a:buNone/>
+            </a:pPr>
+            <a:endParaRPr kumimoji="0" lang="az-Latn-AZ" altLang="en-US" sz="1300" b="0" i="0" u="none" strike="noStrike" cap="none" normalizeH="0" baseline="0">
+              <a:ln>
+                <a:noFill/>
+              </a:ln>
+              <a:solidFill>
+                <a:schemeClr val="tx1"/>
+              </a:solidFill>
+              <a:effectLst/>
+              <a:latin typeface="Arial" panose="020B0604020202020204" pitchFamily="34" charset="0"/>
+            </a:endParaRPr>
+          </a:p>
+          <a:p>
+            <a:pPr>
+              <a:lnSpc>
+                <a:spcPct val="150000"/>
+              </a:lnSpc>
+              <a:buNone/>
+            </a:pPr>
+            <a:endParaRPr lang="az-Latn-AZ" altLang="en-US" sz="1300">
+              <a:latin typeface="Arial" panose="020B0604020202020204" pitchFamily="34" charset="0"/>
+            </a:endParaRPr>
+          </a:p>
+          <a:p>
+            <a:pPr>
+              <a:lnSpc>
+                <a:spcPct val="150000"/>
+              </a:lnSpc>
+              <a:buNone/>
+            </a:pPr>
+            <a:endParaRPr kumimoji="0" lang="az-Latn-AZ" altLang="en-US" sz="1300" b="0" i="0" u="none" strike="noStrike" cap="none" normalizeH="0" baseline="0">
+              <a:ln>
+                <a:noFill/>
+              </a:ln>
+              <a:solidFill>
+                <a:schemeClr val="tx1"/>
+              </a:solidFill>
+              <a:effectLst/>
+              <a:latin typeface="Arial" panose="020B0604020202020204" pitchFamily="34" charset="0"/>
+            </a:endParaRPr>
+          </a:p>
+          <a:p>
+            <a:pPr>
+              <a:lnSpc>
+                <a:spcPct val="150000"/>
+              </a:lnSpc>
+              <a:buNone/>
+            </a:pPr>
+            <a:endParaRPr lang="az-Latn-AZ" altLang="en-US" sz="1300">
+              <a:latin typeface="Arial" panose="020B0604020202020204" pitchFamily="34" charset="0"/>
+            </a:endParaRPr>
+          </a:p>
+          <a:p>
+            <a:pPr>
+              <a:lnSpc>
+                <a:spcPct val="150000"/>
+              </a:lnSpc>
+              <a:buNone/>
+            </a:pPr>
+            <a:endParaRPr lang="az-Latn-AZ" altLang="en-US" sz="1300">
+              <a:latin typeface="Arial" panose="020B0604020202020204" pitchFamily="34" charset="0"/>
+            </a:endParaRPr>
+          </a:p>
+          <a:p>
+            <a:pPr>
+              <a:lnSpc>
+                <a:spcPct val="150000"/>
+              </a:lnSpc>
+              <a:buNone/>
+            </a:pPr>
+            <a:r>
+              <a:rPr kumimoji="0" lang="az-Latn-AZ" altLang="en-US" sz="1300" b="0" i="0" u="none" strike="noStrike" cap="none" normalizeH="0" baseline="0">
+                <a:ln>
+                  <a:noFill/>
+                </a:ln>
+                <a:solidFill>
+                  <a:schemeClr val="tx1"/>
+                </a:solidFill>
+                <a:effectLst/>
+                <a:latin typeface="Arial" panose="020B0604020202020204" pitchFamily="34" charset="0"/>
+              </a:rPr>
+              <a:t>növbəti dərsdə kodda bir balaca dəyişiklik edəcəyik.</a:t>
+            </a:r>
+            <a:endParaRPr kumimoji="0" lang="en-US" altLang="en-US" sz="1300" b="0" i="0" u="none" strike="noStrike" cap="none" normalizeH="0" baseline="0">
+              <a:ln>
+                <a:noFill/>
+              </a:ln>
+              <a:solidFill>
+                <a:schemeClr val="tx1"/>
+              </a:solidFill>
+              <a:effectLst/>
+              <a:latin typeface="Arial" panose="020B0604020202020204" pitchFamily="34" charset="0"/>
+            </a:endParaRPr>
+          </a:p>
+        </p:txBody>
+      </p:sp>
+      <p:pic>
+        <p:nvPicPr>
+          <p:cNvPr id="4" name="Picture 3">
+            <a:extLst>
+              <a:ext uri="{FF2B5EF4-FFF2-40B4-BE49-F238E27FC236}">
+                <a16:creationId xmlns:a16="http://schemas.microsoft.com/office/drawing/2014/main" id="{BEBC63D8-5239-262F-1EFB-E4AD8DE8E00C}"/>
+              </a:ext>
+            </a:extLst>
+          </p:cNvPr>
+          <p:cNvPicPr>
+            <a:picLocks noChangeAspect="1"/>
+          </p:cNvPicPr>
+          <p:nvPr/>
+        </p:nvPicPr>
+        <p:blipFill>
+          <a:blip r:embed="rId2"/>
+          <a:stretch>
+            <a:fillRect/>
+          </a:stretch>
+        </p:blipFill>
+        <p:spPr>
+          <a:xfrm>
+            <a:off x="5120936" y="0"/>
+            <a:ext cx="7071064" cy="6858000"/>
+          </a:xfrm>
+          <a:prstGeom prst="rect">
+            <a:avLst/>
+          </a:prstGeom>
+        </p:spPr>
+      </p:pic>
+    </p:spTree>
+    <p:extLst>
+      <p:ext uri="{BB962C8B-B14F-4D97-AF65-F5344CB8AC3E}">
+        <p14:creationId xmlns:p14="http://schemas.microsoft.com/office/powerpoint/2010/main" val="1233521936"/>
+      </p:ext>
+    </p:extLst>
+  </p:cSld>
+  <p:clrMapOvr>
+    <a:masterClrMapping/>
+  </p:clrMapOvr>
+</p:sld>
+</file>
+
+<file path=ppt/slides/slide9.xml><?xml version="1.0" encoding="utf-8"?>
+<p:sld xmlns:a="http://schemas.openxmlformats.org/drawingml/2006/main" xmlns:r="http://schemas.openxmlformats.org/officeDocument/2006/relationships" xmlns:p="http://schemas.openxmlformats.org/presentationml/2006/main">
+  <p:cSld>
+    <p:spTree>
+      <p:nvGrpSpPr>
+        <p:cNvPr id="1" name="">
+          <a:extLst>
+            <a:ext uri="{FF2B5EF4-FFF2-40B4-BE49-F238E27FC236}">
+              <a16:creationId xmlns:a16="http://schemas.microsoft.com/office/drawing/2014/main" id="{870EF6A5-E3D6-A2E6-27DD-981D4BD476EE}"/>
+            </a:ext>
+          </a:extLst>
+        </p:cNvPr>
+        <p:cNvGrpSpPr/>
+        <p:nvPr/>
+      </p:nvGrpSpPr>
+      <p:grpSpPr>
+        <a:xfrm>
+          <a:off x="0" y="0"/>
+          <a:ext cx="0" cy="0"/>
+          <a:chOff x="0" y="0"/>
+          <a:chExt cx="0" cy="0"/>
+        </a:xfrm>
+      </p:grpSpPr>
+      <p:sp>
+        <p:nvSpPr>
+          <p:cNvPr id="3" name="TextBox 2">
+            <a:extLst>
+              <a:ext uri="{FF2B5EF4-FFF2-40B4-BE49-F238E27FC236}">
+                <a16:creationId xmlns:a16="http://schemas.microsoft.com/office/drawing/2014/main" id="{E79769AD-1BD3-DD37-2A00-C9554337328A}"/>
               </a:ext>
             </a:extLst>
           </p:cNvPr>
@@ -3559,7 +5121,7 @@
     </p:spTree>
     <p:extLst>
       <p:ext uri="{BB962C8B-B14F-4D97-AF65-F5344CB8AC3E}">
-        <p14:creationId xmlns:p14="http://schemas.microsoft.com/office/powerpoint/2010/main" val="3095838342"/>
+        <p14:creationId xmlns:p14="http://schemas.microsoft.com/office/powerpoint/2010/main" val="324421866"/>
       </p:ext>
     </p:extLst>
   </p:cSld>

</xml_diff>